<commit_message>
Styling changes to presentation
Added Cantarell font family
</commit_message>
<xml_diff>
--- a/documentation/TORMA Biztonságtechnika.pptx
+++ b/documentation/TORMA Biztonságtechnika.pptx
@@ -15,15 +15,16 @@
   <p:notesSz cx="6858000" cy="9144000"/>
   <p:embeddedFontLst>
     <p:embeddedFont>
-      <p:font typeface="Candara" panose="020E0502030303020204" pitchFamily="34" charset="0"/>
-      <p:regular r:id="rId7"/>
-      <p:bold r:id="rId8"/>
-      <p:italic r:id="rId9"/>
-      <p:boldItalic r:id="rId10"/>
+      <p:font typeface="Cantarell" pitchFamily="50" charset="0"/>
+      <p:bold r:id="rId7"/>
     </p:embeddedFont>
     <p:embeddedFont>
-      <p:font typeface="Cantarell Classified" panose="020B0604020202020204" charset="0"/>
-      <p:bold r:id="rId11"/>
+      <p:font typeface="Cantarell Classified" pitchFamily="50" charset="0"/>
+      <p:bold r:id="rId8"/>
+    </p:embeddedFont>
+    <p:embeddedFont>
+      <p:font typeface="Cantarell Regular" pitchFamily="50" charset="0"/>
+      <p:regular r:id="rId9"/>
     </p:embeddedFont>
   </p:embeddedFontLst>
   <p:defaultTextStyle>
@@ -3408,7 +3409,9 @@
         </p:nvSpPr>
         <p:spPr/>
         <p:txBody>
-          <a:bodyPr/>
+          <a:bodyPr>
+            <a:normAutofit/>
+          </a:bodyPr>
           <a:lstStyle/>
           <a:p>
             <a:r>
@@ -3416,9 +3419,9 @@
                 <a:solidFill>
                   <a:srgbClr val="FEFCFB"/>
                 </a:solidFill>
-                <a:latin typeface="Candara" panose="020E0502030303020204" pitchFamily="34" charset="0"/>
+                <a:latin typeface="Cantarell Regular" pitchFamily="50" charset="0"/>
               </a:rPr>
-              <a:t>készítette: Czéh Szabolcs, Gonda Ákos, Torma Enikő</a:t>
+              <a:t>a presentation by Czéh Szabolcs, Gonda Ákos &amp; Torma Enikő</a:t>
             </a:r>
           </a:p>
         </p:txBody>
@@ -3480,6 +3483,7 @@
                 <a:solidFill>
                   <a:schemeClr val="bg1"/>
                 </a:solidFill>
+                <a:latin typeface="Cantarell" pitchFamily="50" charset="0"/>
               </a:rPr>
               <a:t>Teamwork</a:t>
             </a:r>
@@ -3516,6 +3520,7 @@
                 <a:solidFill>
                   <a:schemeClr val="bg1"/>
                 </a:solidFill>
+                <a:latin typeface="Cantarell Regular" pitchFamily="50" charset="0"/>
               </a:rPr>
               <a:t>Czéh Szabolcs – Backend</a:t>
             </a:r>
@@ -3525,6 +3530,7 @@
               <a:solidFill>
                 <a:schemeClr val="bg1"/>
               </a:solidFill>
+              <a:latin typeface="Cantarell Regular" pitchFamily="50" charset="0"/>
             </a:endParaRPr>
           </a:p>
           <a:p>
@@ -3533,6 +3539,7 @@
                 <a:solidFill>
                   <a:schemeClr val="bg1"/>
                 </a:solidFill>
+                <a:latin typeface="Cantarell Regular" pitchFamily="50" charset="0"/>
               </a:rPr>
               <a:t>Gonda Ákos – Database, Documentation</a:t>
             </a:r>
@@ -3542,6 +3549,7 @@
               <a:solidFill>
                 <a:schemeClr val="bg1"/>
               </a:solidFill>
+              <a:latin typeface="Cantarell Regular" pitchFamily="50" charset="0"/>
             </a:endParaRPr>
           </a:p>
           <a:p>
@@ -3550,6 +3558,7 @@
                 <a:solidFill>
                   <a:schemeClr val="bg1"/>
                 </a:solidFill>
+                <a:latin typeface="Cantarell Regular" pitchFamily="50" charset="0"/>
               </a:rPr>
               <a:t>Torma Enikő – Frontend </a:t>
             </a:r>
@@ -3612,6 +3621,7 @@
                 <a:solidFill>
                   <a:schemeClr val="bg1"/>
                 </a:solidFill>
+                <a:latin typeface="Cantarell" pitchFamily="50" charset="0"/>
               </a:rPr>
               <a:t>The Problem</a:t>
             </a:r>
@@ -3644,6 +3654,7 @@
                 <a:solidFill>
                   <a:schemeClr val="bg1"/>
                 </a:solidFill>
+                <a:latin typeface="Cantarell Regular" pitchFamily="50" charset="0"/>
               </a:rPr>
               <a:t>Torma Security Ltd.’s website is outdated.</a:t>
             </a:r>
@@ -3653,6 +3664,7 @@
               <a:solidFill>
                 <a:schemeClr val="bg1"/>
               </a:solidFill>
+              <a:latin typeface="Cantarell Regular" pitchFamily="50" charset="0"/>
             </a:endParaRPr>
           </a:p>
           <a:p>
@@ -3661,6 +3673,7 @@
                 <a:solidFill>
                   <a:schemeClr val="bg1"/>
                 </a:solidFill>
+                <a:latin typeface="Cantarell Regular" pitchFamily="50" charset="0"/>
               </a:rPr>
               <a:t>Customers don’t usually know what they need.</a:t>
             </a:r>
@@ -3670,6 +3683,7 @@
               <a:solidFill>
                 <a:schemeClr val="bg1"/>
               </a:solidFill>
+              <a:latin typeface="Cantarell Regular" pitchFamily="50" charset="0"/>
             </a:endParaRPr>
           </a:p>
           <a:p>
@@ -3678,6 +3692,7 @@
                 <a:solidFill>
                   <a:schemeClr val="bg1"/>
                 </a:solidFill>
+                <a:latin typeface="Cantarell Regular" pitchFamily="50" charset="0"/>
               </a:rPr>
               <a:t>Hard to get an appointment.</a:t>
             </a:r>
@@ -3687,6 +3702,7 @@
               <a:solidFill>
                 <a:schemeClr val="bg1"/>
               </a:solidFill>
+              <a:latin typeface="Cantarell Regular" pitchFamily="50" charset="0"/>
             </a:endParaRPr>
           </a:p>
           <a:p>
@@ -3695,6 +3711,7 @@
                 <a:solidFill>
                   <a:schemeClr val="bg1"/>
                 </a:solidFill>
+                <a:latin typeface="Cantarell Regular" pitchFamily="50" charset="0"/>
               </a:rPr>
               <a:t>No online presence</a:t>
             </a:r>
@@ -3757,6 +3774,7 @@
                 <a:solidFill>
                   <a:schemeClr val="bg1"/>
                 </a:solidFill>
+                <a:latin typeface="Cantarell" pitchFamily="50" charset="0"/>
               </a:rPr>
               <a:t>Our solution</a:t>
             </a:r>
@@ -3789,6 +3807,7 @@
                 <a:solidFill>
                   <a:schemeClr val="bg1"/>
                 </a:solidFill>
+                <a:latin typeface="Cantarell Regular" pitchFamily="50" charset="0"/>
               </a:rPr>
               <a:t>A new modern website with better UX/UI</a:t>
             </a:r>
@@ -3798,6 +3817,7 @@
               <a:solidFill>
                 <a:schemeClr val="bg1"/>
               </a:solidFill>
+              <a:latin typeface="Cantarell Regular" pitchFamily="50" charset="0"/>
             </a:endParaRPr>
           </a:p>
           <a:p>
@@ -3806,6 +3826,7 @@
                 <a:solidFill>
                   <a:schemeClr val="bg1"/>
                 </a:solidFill>
+                <a:latin typeface="Cantarell Regular" pitchFamily="50" charset="0"/>
               </a:rPr>
               <a:t>Configuration system according to customer needs</a:t>
             </a:r>
@@ -3815,6 +3836,7 @@
               <a:solidFill>
                 <a:schemeClr val="bg1"/>
               </a:solidFill>
+              <a:latin typeface="Cantarell Regular" pitchFamily="50" charset="0"/>
             </a:endParaRPr>
           </a:p>
           <a:p>
@@ -3823,6 +3845,7 @@
                 <a:solidFill>
                   <a:schemeClr val="bg1"/>
                 </a:solidFill>
+                <a:latin typeface="Cantarell Regular" pitchFamily="50" charset="0"/>
               </a:rPr>
               <a:t>Online appointment booking</a:t>
             </a:r>
@@ -3832,6 +3855,7 @@
               <a:solidFill>
                 <a:schemeClr val="bg1"/>
               </a:solidFill>
+              <a:latin typeface="Cantarell Regular" pitchFamily="50" charset="0"/>
             </a:endParaRPr>
           </a:p>
           <a:p>
@@ -3840,6 +3864,7 @@
                 <a:solidFill>
                   <a:schemeClr val="bg1"/>
                 </a:solidFill>
+                <a:latin typeface="Cantarell Regular" pitchFamily="50" charset="0"/>
               </a:rPr>
               <a:t>Online shopping oppourtunity which boosts sales </a:t>
             </a:r>
@@ -3902,6 +3927,7 @@
                 <a:solidFill>
                   <a:schemeClr val="bg1"/>
                 </a:solidFill>
+                <a:latin typeface="Cantarell" pitchFamily="50" charset="0"/>
               </a:rPr>
               <a:t>Technologies used:</a:t>
             </a:r>
@@ -3934,6 +3960,7 @@
                 <a:solidFill>
                   <a:schemeClr val="bg1"/>
                 </a:solidFill>
+                <a:latin typeface="Cantarell Regular" pitchFamily="50" charset="0"/>
               </a:rPr>
               <a:t>Scrum – Trackable deadlines  </a:t>
             </a:r>
@@ -3943,6 +3970,7 @@
               <a:solidFill>
                 <a:schemeClr val="bg1"/>
               </a:solidFill>
+              <a:latin typeface="Cantarell Regular" pitchFamily="50" charset="0"/>
             </a:endParaRPr>
           </a:p>
           <a:p>
@@ -3951,6 +3979,7 @@
                 <a:solidFill>
                   <a:schemeClr val="bg1"/>
                 </a:solidFill>
+                <a:latin typeface="Cantarell Regular" pitchFamily="50" charset="0"/>
               </a:rPr>
               <a:t>Jira – Timelines, Task tracking</a:t>
             </a:r>
@@ -3958,6 +3987,7 @@
               <a:solidFill>
                 <a:schemeClr val="bg1"/>
               </a:solidFill>
+              <a:latin typeface="Cantarell Regular" pitchFamily="50" charset="0"/>
             </a:endParaRPr>
           </a:p>
           <a:p>
@@ -3965,6 +3995,7 @@
               <a:solidFill>
                 <a:schemeClr val="bg1"/>
               </a:solidFill>
+              <a:latin typeface="Cantarell Regular" pitchFamily="50" charset="0"/>
             </a:endParaRPr>
           </a:p>
           <a:p>
@@ -3973,6 +4004,7 @@
                 <a:solidFill>
                   <a:schemeClr val="bg1"/>
                 </a:solidFill>
+                <a:latin typeface="Cantarell Regular" pitchFamily="50" charset="0"/>
               </a:rPr>
               <a:t>Git – Version controller </a:t>
             </a:r>
@@ -3982,6 +4014,7 @@
               <a:solidFill>
                 <a:schemeClr val="bg1"/>
               </a:solidFill>
+              <a:latin typeface="Cantarell Regular" pitchFamily="50" charset="0"/>
             </a:endParaRPr>
           </a:p>
           <a:p>
@@ -3990,6 +4023,7 @@
                 <a:solidFill>
                   <a:schemeClr val="bg1"/>
                 </a:solidFill>
+                <a:latin typeface="Cantarell Regular" pitchFamily="50" charset="0"/>
               </a:rPr>
               <a:t>Discord – Team communication</a:t>
             </a:r>
@@ -3998,6 +4032,7 @@
                 <a:solidFill>
                   <a:schemeClr val="bg1"/>
                 </a:solidFill>
+                <a:latin typeface="Cantarell Regular" pitchFamily="50" charset="0"/>
               </a:rPr>
             </a:br>
             <a:br>
@@ -4005,12 +4040,14 @@
                 <a:solidFill>
                   <a:schemeClr val="bg1"/>
                 </a:solidFill>
+                <a:latin typeface="Cantarell Regular" pitchFamily="50" charset="0"/>
               </a:rPr>
             </a:br>
             <a:endParaRPr lang="hu-HU" dirty="0">
               <a:solidFill>
                 <a:schemeClr val="bg1"/>
               </a:solidFill>
+              <a:latin typeface="Cantarell Regular" pitchFamily="50" charset="0"/>
             </a:endParaRPr>
           </a:p>
         </p:txBody>

</xml_diff>

<commit_message>
Added missing .htaccess file
</commit_message>
<xml_diff>
--- a/documentation/TORMA Biztonságtechnika.pptx
+++ b/documentation/TORMA Biztonságtechnika.pptx
@@ -20,17 +20,18 @@
   <p:notesSz cx="6858000" cy="9144000"/>
   <p:embeddedFontLst>
     <p:embeddedFont>
-      <p:font typeface="Cantarell" pitchFamily="50" charset="0"/>
+      <p:font typeface="Cantarell" panose="020B0604020202020204" charset="0"/>
       <p:bold r:id="rId12"/>
     </p:embeddedFont>
     <p:embeddedFont>
-      <p:font typeface="Cantarell Classified" pitchFamily="50" charset="0"/>
+      <p:font typeface="Cantarell Classified" panose="020B0604020202020204" charset="0"/>
       <p:regular r:id="rId13"/>
       <p:bold r:id="rId14"/>
     </p:embeddedFont>
     <p:embeddedFont>
-      <p:font typeface="Cantarell Regular" pitchFamily="50" charset="0"/>
+      <p:font typeface="Cantarell Regular" panose="02000803000000000000" pitchFamily="50" charset="0"/>
       <p:regular r:id="rId15"/>
+      <p:bold r:id="rId16"/>
     </p:embeddedFont>
   </p:embeddedFontLst>
   <p:defaultTextStyle>
@@ -5144,7 +5145,7 @@
 <dgm:dataModel xmlns:dgm="http://schemas.openxmlformats.org/drawingml/2006/diagram" xmlns:a="http://schemas.openxmlformats.org/drawingml/2006/main">
   <dgm:ptLst>
     <dgm:pt modelId="{85D8B80F-9A50-4182-B3F7-A62FA4D356C4}" type="doc">
-      <dgm:prSet loTypeId="urn:microsoft.com/office/officeart/2016/7/layout/BasicLinearProcessNumbered" loCatId="process" qsTypeId="urn:microsoft.com/office/officeart/2005/8/quickstyle/simple1" qsCatId="simple" csTypeId="urn:microsoft.com/office/officeart/2005/8/colors/colorful2" csCatId="colorful"/>
+      <dgm:prSet loTypeId="urn:microsoft.com/office/officeart/2016/7/layout/BasicLinearProcessNumbered" loCatId="process" qsTypeId="urn:microsoft.com/office/officeart/2005/8/quickstyle/simple1" qsCatId="simple" csTypeId="urn:microsoft.com/office/officeart/2005/8/colors/colorful2" csCatId="colorful" phldr="1"/>
       <dgm:spPr/>
       <dgm:t>
         <a:bodyPr/>
@@ -5242,10 +5243,18 @@
         <a:lstStyle/>
         <a:p>
           <a:r>
-            <a:rPr lang="hu-HU"/>
-            <a:t>Ensure long.term maintenance and update</a:t>
+            <a:rPr lang="hu-HU" dirty="0"/>
+            <a:t>Ensure long</a:t>
           </a:r>
-          <a:endParaRPr lang="en-US"/>
+          <a:r>
+            <a:rPr lang="en-US" dirty="0"/>
+            <a:t> </a:t>
+          </a:r>
+          <a:r>
+            <a:rPr lang="hu-HU" dirty="0"/>
+            <a:t>term maintenance and update</a:t>
+          </a:r>
+          <a:endParaRPr lang="en-US" dirty="0"/>
         </a:p>
       </dgm:t>
     </dgm:pt>
@@ -5634,12 +5643,12 @@
         <a:fontRef idx="minor"/>
       </dsp:style>
       <dsp:txBody>
-        <a:bodyPr spcFirstLastPara="0" vert="horz" wrap="square" lIns="118110" tIns="118110" rIns="118110" bIns="118110" numCol="1" spcCol="1270" anchor="ctr" anchorCtr="0">
+        <a:bodyPr spcFirstLastPara="0" vert="horz" wrap="square" lIns="114300" tIns="114300" rIns="114300" bIns="114300" numCol="1" spcCol="1270" anchor="ctr" anchorCtr="0">
           <a:noAutofit/>
         </a:bodyPr>
         <a:lstStyle/>
         <a:p>
-          <a:pPr marL="0" lvl="0" indent="0" algn="ctr" defTabSz="1377950">
+          <a:pPr marL="0" lvl="0" indent="0" algn="ctr" defTabSz="1333500">
             <a:lnSpc>
               <a:spcPct val="90000"/>
             </a:lnSpc>
@@ -5652,12 +5661,12 @@
             <a:buNone/>
           </a:pPr>
           <a:r>
-            <a:rPr lang="hu-HU" sz="3100" kern="1200">
+            <a:rPr lang="hu-HU" sz="3000" kern="1200">
               <a:latin typeface="Cantarell Regular" pitchFamily="50" charset="0"/>
             </a:rPr>
             <a:t>Czéh Szabolcs – Backend</a:t>
           </a:r>
-          <a:endParaRPr lang="en-US" sz="3100" kern="1200">
+          <a:endParaRPr lang="en-US" sz="3000" kern="1200">
             <a:latin typeface="Cantarell Regular" pitchFamily="50" charset="0"/>
           </a:endParaRPr>
         </a:p>
@@ -5770,12 +5779,12 @@
         <a:fontRef idx="minor"/>
       </dsp:style>
       <dsp:txBody>
-        <a:bodyPr spcFirstLastPara="0" vert="horz" wrap="square" lIns="118110" tIns="118110" rIns="118110" bIns="118110" numCol="1" spcCol="1270" anchor="ctr" anchorCtr="0">
+        <a:bodyPr spcFirstLastPara="0" vert="horz" wrap="square" lIns="114300" tIns="114300" rIns="114300" bIns="114300" numCol="1" spcCol="1270" anchor="ctr" anchorCtr="0">
           <a:noAutofit/>
         </a:bodyPr>
         <a:lstStyle/>
         <a:p>
-          <a:pPr marL="0" lvl="0" indent="0" algn="ctr" defTabSz="1377950">
+          <a:pPr marL="0" lvl="0" indent="0" algn="ctr" defTabSz="1333500">
             <a:lnSpc>
               <a:spcPct val="90000"/>
             </a:lnSpc>
@@ -5788,12 +5797,12 @@
             <a:buNone/>
           </a:pPr>
           <a:r>
-            <a:rPr lang="hu-HU" sz="3100" kern="1200">
+            <a:rPr lang="hu-HU" sz="3000" kern="1200">
               <a:latin typeface="Cantarell Regular" pitchFamily="50" charset="0"/>
             </a:rPr>
             <a:t>Gonda Ákos – Database, Documentation</a:t>
           </a:r>
-          <a:endParaRPr lang="en-US" sz="3100" kern="1200">
+          <a:endParaRPr lang="en-US" sz="3000" kern="1200">
             <a:latin typeface="Cantarell Regular" pitchFamily="50" charset="0"/>
           </a:endParaRPr>
         </a:p>
@@ -5906,12 +5915,12 @@
         <a:fontRef idx="minor"/>
       </dsp:style>
       <dsp:txBody>
-        <a:bodyPr spcFirstLastPara="0" vert="horz" wrap="square" lIns="118110" tIns="118110" rIns="118110" bIns="118110" numCol="1" spcCol="1270" anchor="ctr" anchorCtr="0">
+        <a:bodyPr spcFirstLastPara="0" vert="horz" wrap="square" lIns="114300" tIns="114300" rIns="114300" bIns="114300" numCol="1" spcCol="1270" anchor="ctr" anchorCtr="0">
           <a:noAutofit/>
         </a:bodyPr>
         <a:lstStyle/>
         <a:p>
-          <a:pPr marL="0" lvl="0" indent="0" algn="ctr" defTabSz="1377950">
+          <a:pPr marL="0" lvl="0" indent="0" algn="ctr" defTabSz="1333500">
             <a:lnSpc>
               <a:spcPct val="90000"/>
             </a:lnSpc>
@@ -5924,12 +5933,12 @@
             <a:buNone/>
           </a:pPr>
           <a:r>
-            <a:rPr lang="hu-HU" sz="3100" kern="1200">
+            <a:rPr lang="hu-HU" sz="3000" kern="1200">
               <a:latin typeface="Cantarell Regular" pitchFamily="50" charset="0"/>
             </a:rPr>
             <a:t>Torma Enikő – Frontend </a:t>
           </a:r>
-          <a:endParaRPr lang="en-US" sz="3100" kern="1200">
+          <a:endParaRPr lang="en-US" sz="3000" kern="1200">
             <a:latin typeface="Cantarell Regular" pitchFamily="50" charset="0"/>
           </a:endParaRPr>
         </a:p>
@@ -6557,12 +6566,12 @@
         </a:fontRef>
       </dsp:style>
       <dsp:txBody>
-        <a:bodyPr spcFirstLastPara="0" vert="horz" wrap="square" lIns="64770" tIns="64770" rIns="64770" bIns="64770" numCol="1" spcCol="1270" anchor="ctr" anchorCtr="0">
+        <a:bodyPr spcFirstLastPara="0" vert="horz" wrap="square" lIns="60960" tIns="60960" rIns="60960" bIns="60960" numCol="1" spcCol="1270" anchor="ctr" anchorCtr="0">
           <a:noAutofit/>
         </a:bodyPr>
         <a:lstStyle/>
         <a:p>
-          <a:pPr marL="0" lvl="0" indent="0" algn="ctr" defTabSz="755650">
+          <a:pPr marL="0" lvl="0" indent="0" algn="ctr" defTabSz="711200">
             <a:lnSpc>
               <a:spcPct val="90000"/>
             </a:lnSpc>
@@ -6575,12 +6584,12 @@
             <a:buNone/>
           </a:pPr>
           <a:r>
-            <a:rPr lang="hu-HU" sz="1700" kern="1200">
+            <a:rPr lang="hu-HU" sz="1600" kern="1200">
               <a:latin typeface="Cantarell Regular" pitchFamily="50" charset="0"/>
             </a:rPr>
             <a:t>A new modern website with better UX/UI</a:t>
           </a:r>
-          <a:endParaRPr lang="en-US" sz="1700" kern="1200">
+          <a:endParaRPr lang="en-US" sz="1600" kern="1200">
             <a:latin typeface="Cantarell Regular" pitchFamily="50" charset="0"/>
           </a:endParaRPr>
         </a:p>
@@ -6640,12 +6649,12 @@
         </a:fontRef>
       </dsp:style>
       <dsp:txBody>
-        <a:bodyPr spcFirstLastPara="0" vert="horz" wrap="square" lIns="64770" tIns="64770" rIns="64770" bIns="64770" numCol="1" spcCol="1270" anchor="ctr" anchorCtr="0">
+        <a:bodyPr spcFirstLastPara="0" vert="horz" wrap="square" lIns="60960" tIns="60960" rIns="60960" bIns="60960" numCol="1" spcCol="1270" anchor="ctr" anchorCtr="0">
           <a:noAutofit/>
         </a:bodyPr>
         <a:lstStyle/>
         <a:p>
-          <a:pPr marL="0" lvl="0" indent="0" algn="ctr" defTabSz="755650">
+          <a:pPr marL="0" lvl="0" indent="0" algn="ctr" defTabSz="711200">
             <a:lnSpc>
               <a:spcPct val="90000"/>
             </a:lnSpc>
@@ -6658,12 +6667,12 @@
             <a:buNone/>
           </a:pPr>
           <a:r>
-            <a:rPr lang="hu-HU" sz="1700" kern="1200">
+            <a:rPr lang="hu-HU" sz="1600" kern="1200">
               <a:latin typeface="Cantarell Regular" pitchFamily="50" charset="0"/>
             </a:rPr>
             <a:t>Configuration system according to customer needs</a:t>
           </a:r>
-          <a:endParaRPr lang="en-US" sz="1700" kern="1200">
+          <a:endParaRPr lang="en-US" sz="1600" kern="1200">
             <a:latin typeface="Cantarell Regular" pitchFamily="50" charset="0"/>
           </a:endParaRPr>
         </a:p>
@@ -6723,12 +6732,12 @@
         </a:fontRef>
       </dsp:style>
       <dsp:txBody>
-        <a:bodyPr spcFirstLastPara="0" vert="horz" wrap="square" lIns="64770" tIns="64770" rIns="64770" bIns="64770" numCol="1" spcCol="1270" anchor="ctr" anchorCtr="0">
+        <a:bodyPr spcFirstLastPara="0" vert="horz" wrap="square" lIns="60960" tIns="60960" rIns="60960" bIns="60960" numCol="1" spcCol="1270" anchor="ctr" anchorCtr="0">
           <a:noAutofit/>
         </a:bodyPr>
         <a:lstStyle/>
         <a:p>
-          <a:pPr marL="0" lvl="0" indent="0" algn="ctr" defTabSz="755650">
+          <a:pPr marL="0" lvl="0" indent="0" algn="ctr" defTabSz="711200">
             <a:lnSpc>
               <a:spcPct val="90000"/>
             </a:lnSpc>
@@ -6741,12 +6750,12 @@
             <a:buNone/>
           </a:pPr>
           <a:r>
-            <a:rPr lang="hu-HU" sz="1700" kern="1200">
+            <a:rPr lang="hu-HU" sz="1600" kern="1200">
               <a:latin typeface="Cantarell Regular" pitchFamily="50" charset="0"/>
             </a:rPr>
             <a:t>Online appointment booking</a:t>
           </a:r>
-          <a:endParaRPr lang="en-US" sz="1700" kern="1200">
+          <a:endParaRPr lang="en-US" sz="1600" kern="1200">
             <a:latin typeface="Cantarell Regular" pitchFamily="50" charset="0"/>
           </a:endParaRPr>
         </a:p>
@@ -6806,12 +6815,12 @@
         </a:fontRef>
       </dsp:style>
       <dsp:txBody>
-        <a:bodyPr spcFirstLastPara="0" vert="horz" wrap="square" lIns="64770" tIns="64770" rIns="64770" bIns="64770" numCol="1" spcCol="1270" anchor="ctr" anchorCtr="0">
+        <a:bodyPr spcFirstLastPara="0" vert="horz" wrap="square" lIns="60960" tIns="60960" rIns="60960" bIns="60960" numCol="1" spcCol="1270" anchor="ctr" anchorCtr="0">
           <a:noAutofit/>
         </a:bodyPr>
         <a:lstStyle/>
         <a:p>
-          <a:pPr marL="0" lvl="0" indent="0" algn="ctr" defTabSz="755650">
+          <a:pPr marL="0" lvl="0" indent="0" algn="ctr" defTabSz="711200">
             <a:lnSpc>
               <a:spcPct val="90000"/>
             </a:lnSpc>
@@ -6824,12 +6833,12 @@
             <a:buNone/>
           </a:pPr>
           <a:r>
-            <a:rPr lang="hu-HU" sz="1700" kern="1200">
+            <a:rPr lang="hu-HU" sz="1600" kern="1200">
               <a:latin typeface="Cantarell Regular" pitchFamily="50" charset="0"/>
             </a:rPr>
             <a:t>Online shopping oppourtunity which boosts sales </a:t>
           </a:r>
-          <a:endParaRPr lang="en-US" sz="1700" kern="1200">
+          <a:endParaRPr lang="en-US" sz="1600" kern="1200">
             <a:latin typeface="Cantarell Regular" pitchFamily="50" charset="0"/>
           </a:endParaRPr>
         </a:p>
@@ -6954,12 +6963,12 @@
         <a:fontRef idx="minor"/>
       </dsp:style>
       <dsp:txBody>
-        <a:bodyPr spcFirstLastPara="0" vert="horz" wrap="square" lIns="87630" tIns="87630" rIns="87630" bIns="87630" numCol="1" spcCol="1270" anchor="ctr" anchorCtr="0">
+        <a:bodyPr spcFirstLastPara="0" vert="horz" wrap="square" lIns="83820" tIns="83820" rIns="83820" bIns="83820" numCol="1" spcCol="1270" anchor="ctr" anchorCtr="0">
           <a:noAutofit/>
         </a:bodyPr>
         <a:lstStyle/>
         <a:p>
-          <a:pPr marL="0" lvl="0" indent="0" algn="ctr" defTabSz="1022350">
+          <a:pPr marL="0" lvl="0" indent="0" algn="ctr" defTabSz="977900">
             <a:lnSpc>
               <a:spcPct val="90000"/>
             </a:lnSpc>
@@ -6972,12 +6981,12 @@
             <a:buNone/>
           </a:pPr>
           <a:r>
-            <a:rPr lang="hu-HU" sz="2300" kern="1200">
+            <a:rPr lang="hu-HU" sz="2200" kern="1200">
               <a:latin typeface="Cantarell Regular" pitchFamily="50" charset="0"/>
             </a:rPr>
             <a:t>Scrum – Trackable deadlines  </a:t>
           </a:r>
-          <a:endParaRPr lang="en-US" sz="2300" kern="1200">
+          <a:endParaRPr lang="en-US" sz="2200" kern="1200">
             <a:latin typeface="Cantarell Regular" pitchFamily="50" charset="0"/>
           </a:endParaRPr>
         </a:p>
@@ -7090,12 +7099,12 @@
         <a:fontRef idx="minor"/>
       </dsp:style>
       <dsp:txBody>
-        <a:bodyPr spcFirstLastPara="0" vert="horz" wrap="square" lIns="87630" tIns="87630" rIns="87630" bIns="87630" numCol="1" spcCol="1270" anchor="ctr" anchorCtr="0">
+        <a:bodyPr spcFirstLastPara="0" vert="horz" wrap="square" lIns="83820" tIns="83820" rIns="83820" bIns="83820" numCol="1" spcCol="1270" anchor="ctr" anchorCtr="0">
           <a:noAutofit/>
         </a:bodyPr>
         <a:lstStyle/>
         <a:p>
-          <a:pPr marL="0" lvl="0" indent="0" algn="ctr" defTabSz="1022350">
+          <a:pPr marL="0" lvl="0" indent="0" algn="ctr" defTabSz="977900">
             <a:lnSpc>
               <a:spcPct val="90000"/>
             </a:lnSpc>
@@ -7108,12 +7117,12 @@
             <a:buNone/>
           </a:pPr>
           <a:r>
-            <a:rPr lang="hu-HU" sz="2300" kern="1200">
+            <a:rPr lang="hu-HU" sz="2200" kern="1200">
               <a:latin typeface="Cantarell Regular" pitchFamily="50" charset="0"/>
             </a:rPr>
             <a:t>Jira – Timelines, Task tracking</a:t>
           </a:r>
-          <a:endParaRPr lang="en-US" sz="2300" kern="1200">
+          <a:endParaRPr lang="en-US" sz="2200" kern="1200">
             <a:latin typeface="Cantarell Regular" pitchFamily="50" charset="0"/>
           </a:endParaRPr>
         </a:p>
@@ -7226,12 +7235,12 @@
         <a:fontRef idx="minor"/>
       </dsp:style>
       <dsp:txBody>
-        <a:bodyPr spcFirstLastPara="0" vert="horz" wrap="square" lIns="87630" tIns="87630" rIns="87630" bIns="87630" numCol="1" spcCol="1270" anchor="ctr" anchorCtr="0">
+        <a:bodyPr spcFirstLastPara="0" vert="horz" wrap="square" lIns="83820" tIns="83820" rIns="83820" bIns="83820" numCol="1" spcCol="1270" anchor="ctr" anchorCtr="0">
           <a:noAutofit/>
         </a:bodyPr>
         <a:lstStyle/>
         <a:p>
-          <a:pPr marL="0" lvl="0" indent="0" algn="ctr" defTabSz="1022350">
+          <a:pPr marL="0" lvl="0" indent="0" algn="ctr" defTabSz="977900">
             <a:lnSpc>
               <a:spcPct val="90000"/>
             </a:lnSpc>
@@ -7244,12 +7253,12 @@
             <a:buNone/>
           </a:pPr>
           <a:r>
-            <a:rPr lang="hu-HU" sz="2300" kern="1200">
+            <a:rPr lang="hu-HU" sz="2200" kern="1200">
               <a:latin typeface="Cantarell Regular" pitchFamily="50" charset="0"/>
             </a:rPr>
             <a:t>Git – Version controller </a:t>
           </a:r>
-          <a:endParaRPr lang="en-US" sz="2300" kern="1200">
+          <a:endParaRPr lang="en-US" sz="2200" kern="1200">
             <a:latin typeface="Cantarell Regular" pitchFamily="50" charset="0"/>
           </a:endParaRPr>
         </a:p>
@@ -7362,12 +7371,12 @@
         <a:fontRef idx="minor"/>
       </dsp:style>
       <dsp:txBody>
-        <a:bodyPr spcFirstLastPara="0" vert="horz" wrap="square" lIns="87630" tIns="87630" rIns="87630" bIns="87630" numCol="1" spcCol="1270" anchor="ctr" anchorCtr="0">
+        <a:bodyPr spcFirstLastPara="0" vert="horz" wrap="square" lIns="83820" tIns="83820" rIns="83820" bIns="83820" numCol="1" spcCol="1270" anchor="ctr" anchorCtr="0">
           <a:noAutofit/>
         </a:bodyPr>
         <a:lstStyle/>
         <a:p>
-          <a:pPr marL="0" lvl="0" indent="0" algn="ctr" defTabSz="1022350">
+          <a:pPr marL="0" lvl="0" indent="0" algn="ctr" defTabSz="977900">
             <a:lnSpc>
               <a:spcPct val="90000"/>
             </a:lnSpc>
@@ -7380,12 +7389,12 @@
             <a:buNone/>
           </a:pPr>
           <a:r>
-            <a:rPr lang="hu-HU" sz="2300" kern="1200">
+            <a:rPr lang="hu-HU" sz="2200" kern="1200">
               <a:latin typeface="Cantarell Regular" pitchFamily="50" charset="0"/>
             </a:rPr>
             <a:t>Discord – Team communication</a:t>
           </a:r>
-          <a:endParaRPr lang="en-US" sz="2300" kern="1200">
+          <a:endParaRPr lang="en-US" sz="2200" kern="1200">
             <a:latin typeface="Cantarell Regular" pitchFamily="50" charset="0"/>
           </a:endParaRPr>
         </a:p>
@@ -7895,10 +7904,18 @@
             <a:buNone/>
           </a:pPr>
           <a:r>
-            <a:rPr lang="hu-HU" sz="2300" kern="1200"/>
-            <a:t>Ensure long.term maintenance and update</a:t>
+            <a:rPr lang="hu-HU" sz="2300" kern="1200" dirty="0"/>
+            <a:t>Ensure long</a:t>
           </a:r>
-          <a:endParaRPr lang="en-US" sz="2300" kern="1200"/>
+          <a:r>
+            <a:rPr lang="en-US" sz="2300" kern="1200" dirty="0"/>
+            <a:t> </a:t>
+          </a:r>
+          <a:r>
+            <a:rPr lang="hu-HU" sz="2300" kern="1200" dirty="0"/>
+            <a:t>term maintenance and update</a:t>
+          </a:r>
+          <a:endParaRPr lang="en-US" sz="2300" kern="1200" dirty="0"/>
         </a:p>
       </dsp:txBody>
       <dsp:txXfrm>
@@ -15731,7 +15748,7 @@
           <a:p>
             <a:fld id="{25520991-ED6B-486D-A964-94991A1558B5}" type="datetimeFigureOut">
               <a:rPr lang="en-US" smtClean="0"/>
-              <a:t>1/7/2026</a:t>
+              <a:t>2/12/2026</a:t>
             </a:fld>
             <a:endParaRPr lang="en-US"/>
           </a:p>
@@ -15894,7 +15911,7 @@
           <a:p>
             <a:fld id="{25520991-ED6B-486D-A964-94991A1558B5}" type="datetimeFigureOut">
               <a:rPr lang="en-US" smtClean="0"/>
-              <a:t>1/7/2026</a:t>
+              <a:t>2/12/2026</a:t>
             </a:fld>
             <a:endParaRPr lang="en-US"/>
           </a:p>
@@ -16067,7 +16084,7 @@
           <a:p>
             <a:fld id="{25520991-ED6B-486D-A964-94991A1558B5}" type="datetimeFigureOut">
               <a:rPr lang="en-US" smtClean="0"/>
-              <a:t>1/7/2026</a:t>
+              <a:t>2/12/2026</a:t>
             </a:fld>
             <a:endParaRPr lang="en-US"/>
           </a:p>
@@ -16230,7 +16247,7 @@
           <a:p>
             <a:fld id="{25520991-ED6B-486D-A964-94991A1558B5}" type="datetimeFigureOut">
               <a:rPr lang="en-US" smtClean="0"/>
-              <a:t>1/7/2026</a:t>
+              <a:t>2/12/2026</a:t>
             </a:fld>
             <a:endParaRPr lang="en-US"/>
           </a:p>
@@ -16470,7 +16487,7 @@
           <a:p>
             <a:fld id="{25520991-ED6B-486D-A964-94991A1558B5}" type="datetimeFigureOut">
               <a:rPr lang="en-US" smtClean="0"/>
-              <a:t>1/7/2026</a:t>
+              <a:t>2/12/2026</a:t>
             </a:fld>
             <a:endParaRPr lang="en-US"/>
           </a:p>
@@ -16694,7 +16711,7 @@
           <a:p>
             <a:fld id="{25520991-ED6B-486D-A964-94991A1558B5}" type="datetimeFigureOut">
               <a:rPr lang="en-US" smtClean="0"/>
-              <a:t>1/7/2026</a:t>
+              <a:t>2/12/2026</a:t>
             </a:fld>
             <a:endParaRPr lang="en-US"/>
           </a:p>
@@ -17053,7 +17070,7 @@
           <a:p>
             <a:fld id="{25520991-ED6B-486D-A964-94991A1558B5}" type="datetimeFigureOut">
               <a:rPr lang="en-US" smtClean="0"/>
-              <a:t>1/7/2026</a:t>
+              <a:t>2/12/2026</a:t>
             </a:fld>
             <a:endParaRPr lang="en-US"/>
           </a:p>
@@ -17165,7 +17182,7 @@
           <a:p>
             <a:fld id="{25520991-ED6B-486D-A964-94991A1558B5}" type="datetimeFigureOut">
               <a:rPr lang="en-US" smtClean="0"/>
-              <a:t>1/7/2026</a:t>
+              <a:t>2/12/2026</a:t>
             </a:fld>
             <a:endParaRPr lang="en-US"/>
           </a:p>
@@ -17255,7 +17272,7 @@
           <a:p>
             <a:fld id="{25520991-ED6B-486D-A964-94991A1558B5}" type="datetimeFigureOut">
               <a:rPr lang="en-US" smtClean="0"/>
-              <a:t>1/7/2026</a:t>
+              <a:t>2/12/2026</a:t>
             </a:fld>
             <a:endParaRPr lang="en-US"/>
           </a:p>
@@ -17525,7 +17542,7 @@
           <a:p>
             <a:fld id="{25520991-ED6B-486D-A964-94991A1558B5}" type="datetimeFigureOut">
               <a:rPr lang="en-US" smtClean="0"/>
-              <a:t>1/7/2026</a:t>
+              <a:t>2/12/2026</a:t>
             </a:fld>
             <a:endParaRPr lang="en-US"/>
           </a:p>
@@ -17772,7 +17789,7 @@
           <a:p>
             <a:fld id="{25520991-ED6B-486D-A964-94991A1558B5}" type="datetimeFigureOut">
               <a:rPr lang="en-US" smtClean="0"/>
-              <a:t>1/7/2026</a:t>
+              <a:t>2/12/2026</a:t>
             </a:fld>
             <a:endParaRPr lang="en-US"/>
           </a:p>
@@ -17981,7 +17998,7 @@
           <a:p>
             <a:fld id="{25520991-ED6B-486D-A964-94991A1558B5}" type="datetimeFigureOut">
               <a:rPr lang="en-US" smtClean="0"/>
-              <a:t>1/7/2026</a:t>
+              <a:t>2/12/2026</a:t>
             </a:fld>
             <a:endParaRPr lang="en-US"/>
           </a:p>
@@ -18791,14 +18808,29 @@
           <a:p>
             <a:pPr algn="r"/>
             <a:r>
-              <a:rPr lang="en-US" sz="4800">
+              <a:rPr lang="en-US" sz="4800" dirty="0">
                 <a:solidFill>
                   <a:srgbClr val="FFFFFF"/>
                 </a:solidFill>
                 <a:latin typeface="Cantarell Classified" pitchFamily="50" charset="0"/>
               </a:rPr>
-              <a:t>TORMA Biztonságtechnika</a:t>
+              <a:t>TORMA </a:t>
             </a:r>
+            <a:r>
+              <a:rPr lang="en-US" sz="4800" dirty="0" err="1">
+                <a:solidFill>
+                  <a:srgbClr val="FFFFFF"/>
+                </a:solidFill>
+                <a:latin typeface="Cantarell Classified" pitchFamily="50" charset="0"/>
+              </a:rPr>
+              <a:t>Biztonságtechnika</a:t>
+            </a:r>
+            <a:endParaRPr lang="en-US" sz="4800" dirty="0">
+              <a:solidFill>
+                <a:srgbClr val="FFFFFF"/>
+              </a:solidFill>
+              <a:latin typeface="Cantarell Classified" pitchFamily="50" charset="0"/>
+            </a:endParaRPr>
           </a:p>
         </p:txBody>
       </p:sp>
@@ -19375,7 +19407,7 @@
             <p:ph idx="1"/>
             <p:extLst>
               <p:ext uri="{D42A27DB-BD31-4B8C-83A1-F6EECF244321}">
-                <p14:modId xmlns:p14="http://schemas.microsoft.com/office/powerpoint/2010/main" val="2958075769"/>
+                <p14:modId xmlns:p14="http://schemas.microsoft.com/office/powerpoint/2010/main" val="4226873620"/>
               </p:ext>
             </p:extLst>
           </p:nvPr>
@@ -19390,6 +19422,42 @@
           </a:graphicData>
         </a:graphic>
       </p:graphicFrame>
+      <p:pic>
+        <p:nvPicPr>
+          <p:cNvPr id="3" name="Picture 2">
+            <a:extLst>
+              <a:ext uri="{FF2B5EF4-FFF2-40B4-BE49-F238E27FC236}">
+                <a16:creationId xmlns:a16="http://schemas.microsoft.com/office/drawing/2014/main" id="{240E4694-F19B-69E5-041D-C2CD4D1EE139}"/>
+              </a:ext>
+            </a:extLst>
+          </p:cNvPr>
+          <p:cNvPicPr>
+            <a:picLocks noChangeAspect="1"/>
+          </p:cNvPicPr>
+          <p:nvPr/>
+        </p:nvPicPr>
+        <p:blipFill>
+          <a:blip r:embed="rId7">
+            <a:extLst>
+              <a:ext uri="{28A0092B-C50C-407E-A947-70E740481C1C}">
+                <a14:useLocalDpi xmlns:a14="http://schemas.microsoft.com/office/drawing/2010/main" val="0"/>
+              </a:ext>
+            </a:extLst>
+          </a:blip>
+          <a:stretch>
+            <a:fillRect/>
+          </a:stretch>
+        </p:blipFill>
+        <p:spPr>
+          <a:xfrm>
+            <a:off x="8395021" y="122359"/>
+            <a:ext cx="3472806" cy="1925311"/>
+          </a:xfrm>
+          <a:prstGeom prst="rect">
+            <a:avLst/>
+          </a:prstGeom>
+        </p:spPr>
+      </p:pic>
     </p:spTree>
   </p:cSld>
   <p:clrMapOvr>
@@ -19799,6 +19867,42 @@
           </a:graphicData>
         </a:graphic>
       </p:graphicFrame>
+      <p:pic>
+        <p:nvPicPr>
+          <p:cNvPr id="4" name="Picture 3">
+            <a:extLst>
+              <a:ext uri="{FF2B5EF4-FFF2-40B4-BE49-F238E27FC236}">
+                <a16:creationId xmlns:a16="http://schemas.microsoft.com/office/drawing/2014/main" id="{9A786913-50D1-F158-C593-2CC9BE199E07}"/>
+              </a:ext>
+            </a:extLst>
+          </p:cNvPr>
+          <p:cNvPicPr>
+            <a:picLocks noChangeAspect="1"/>
+          </p:cNvPicPr>
+          <p:nvPr/>
+        </p:nvPicPr>
+        <p:blipFill>
+          <a:blip r:embed="rId7">
+            <a:extLst>
+              <a:ext uri="{28A0092B-C50C-407E-A947-70E740481C1C}">
+                <a14:useLocalDpi xmlns:a14="http://schemas.microsoft.com/office/drawing/2010/main" val="0"/>
+              </a:ext>
+            </a:extLst>
+          </a:blip>
+          <a:stretch>
+            <a:fillRect/>
+          </a:stretch>
+        </p:blipFill>
+        <p:spPr>
+          <a:xfrm>
+            <a:off x="8395021" y="122359"/>
+            <a:ext cx="3472806" cy="1925311"/>
+          </a:xfrm>
+          <a:prstGeom prst="rect">
+            <a:avLst/>
+          </a:prstGeom>
+        </p:spPr>
+      </p:pic>
     </p:spTree>
   </p:cSld>
   <p:clrMapOvr>
@@ -20200,6 +20304,42 @@
           </a:graphicData>
         </a:graphic>
       </p:graphicFrame>
+      <p:pic>
+        <p:nvPicPr>
+          <p:cNvPr id="3" name="Picture 2">
+            <a:extLst>
+              <a:ext uri="{FF2B5EF4-FFF2-40B4-BE49-F238E27FC236}">
+                <a16:creationId xmlns:a16="http://schemas.microsoft.com/office/drawing/2014/main" id="{049B59D0-DD56-CA86-1E55-8C6B48CDDA5C}"/>
+              </a:ext>
+            </a:extLst>
+          </p:cNvPr>
+          <p:cNvPicPr>
+            <a:picLocks noChangeAspect="1"/>
+          </p:cNvPicPr>
+          <p:nvPr/>
+        </p:nvPicPr>
+        <p:blipFill>
+          <a:blip r:embed="rId7">
+            <a:extLst>
+              <a:ext uri="{28A0092B-C50C-407E-A947-70E740481C1C}">
+                <a14:useLocalDpi xmlns:a14="http://schemas.microsoft.com/office/drawing/2010/main" val="0"/>
+              </a:ext>
+            </a:extLst>
+          </a:blip>
+          <a:stretch>
+            <a:fillRect/>
+          </a:stretch>
+        </p:blipFill>
+        <p:spPr>
+          <a:xfrm>
+            <a:off x="8395021" y="122359"/>
+            <a:ext cx="3472806" cy="1925311"/>
+          </a:xfrm>
+          <a:prstGeom prst="rect">
+            <a:avLst/>
+          </a:prstGeom>
+        </p:spPr>
+      </p:pic>
     </p:spTree>
   </p:cSld>
   <p:clrMapOvr>
@@ -20600,6 +20740,42 @@
           </a:graphicData>
         </a:graphic>
       </p:graphicFrame>
+      <p:pic>
+        <p:nvPicPr>
+          <p:cNvPr id="3" name="Picture 2">
+            <a:extLst>
+              <a:ext uri="{FF2B5EF4-FFF2-40B4-BE49-F238E27FC236}">
+                <a16:creationId xmlns:a16="http://schemas.microsoft.com/office/drawing/2014/main" id="{762E0993-D2BC-A5CB-909A-98226C7FA7B9}"/>
+              </a:ext>
+            </a:extLst>
+          </p:cNvPr>
+          <p:cNvPicPr>
+            <a:picLocks noChangeAspect="1"/>
+          </p:cNvPicPr>
+          <p:nvPr/>
+        </p:nvPicPr>
+        <p:blipFill>
+          <a:blip r:embed="rId7" cstate="print">
+            <a:extLst>
+              <a:ext uri="{28A0092B-C50C-407E-A947-70E740481C1C}">
+                <a14:useLocalDpi xmlns:a14="http://schemas.microsoft.com/office/drawing/2010/main" val="0"/>
+              </a:ext>
+            </a:extLst>
+          </a:blip>
+          <a:stretch>
+            <a:fillRect/>
+          </a:stretch>
+        </p:blipFill>
+        <p:spPr>
+          <a:xfrm>
+            <a:off x="8813129" y="40791"/>
+            <a:ext cx="2694597" cy="1493875"/>
+          </a:xfrm>
+          <a:prstGeom prst="rect">
+            <a:avLst/>
+          </a:prstGeom>
+        </p:spPr>
+      </p:pic>
     </p:spTree>
   </p:cSld>
   <p:clrMapOvr>
@@ -21135,6 +21311,42 @@
           <a:xfrm>
             <a:off x="9015350" y="2328248"/>
             <a:ext cx="2502910" cy="3749677"/>
+          </a:xfrm>
+          <a:prstGeom prst="rect">
+            <a:avLst/>
+          </a:prstGeom>
+        </p:spPr>
+      </p:pic>
+      <p:pic>
+        <p:nvPicPr>
+          <p:cNvPr id="8" name="Picture 7">
+            <a:extLst>
+              <a:ext uri="{FF2B5EF4-FFF2-40B4-BE49-F238E27FC236}">
+                <a16:creationId xmlns:a16="http://schemas.microsoft.com/office/drawing/2014/main" id="{7648D4A5-4817-64AB-ACDA-702345E1A5D4}"/>
+              </a:ext>
+            </a:extLst>
+          </p:cNvPr>
+          <p:cNvPicPr>
+            <a:picLocks noChangeAspect="1"/>
+          </p:cNvPicPr>
+          <p:nvPr/>
+        </p:nvPicPr>
+        <p:blipFill>
+          <a:blip r:embed="rId6" cstate="print">
+            <a:extLst>
+              <a:ext uri="{28A0092B-C50C-407E-A947-70E740481C1C}">
+                <a14:useLocalDpi xmlns:a14="http://schemas.microsoft.com/office/drawing/2010/main" val="0"/>
+              </a:ext>
+            </a:extLst>
+          </a:blip>
+          <a:stretch>
+            <a:fillRect/>
+          </a:stretch>
+        </p:blipFill>
+        <p:spPr>
+          <a:xfrm>
+            <a:off x="8813129" y="40791"/>
+            <a:ext cx="2694597" cy="1493875"/>
           </a:xfrm>
           <a:prstGeom prst="rect">
             <a:avLst/>
@@ -22166,6 +22378,42 @@
           </a:graphicData>
         </a:graphic>
       </p:graphicFrame>
+      <p:pic>
+        <p:nvPicPr>
+          <p:cNvPr id="3" name="Picture 2">
+            <a:extLst>
+              <a:ext uri="{FF2B5EF4-FFF2-40B4-BE49-F238E27FC236}">
+                <a16:creationId xmlns:a16="http://schemas.microsoft.com/office/drawing/2014/main" id="{36BBE26B-88A7-36C7-3776-1AA727FD9CB8}"/>
+              </a:ext>
+            </a:extLst>
+          </p:cNvPr>
+          <p:cNvPicPr>
+            <a:picLocks noChangeAspect="1"/>
+          </p:cNvPicPr>
+          <p:nvPr/>
+        </p:nvPicPr>
+        <p:blipFill>
+          <a:blip r:embed="rId7">
+            <a:extLst>
+              <a:ext uri="{28A0092B-C50C-407E-A947-70E740481C1C}">
+                <a14:useLocalDpi xmlns:a14="http://schemas.microsoft.com/office/drawing/2010/main" val="0"/>
+              </a:ext>
+            </a:extLst>
+          </a:blip>
+          <a:stretch>
+            <a:fillRect/>
+          </a:stretch>
+        </p:blipFill>
+        <p:spPr>
+          <a:xfrm>
+            <a:off x="8395021" y="122359"/>
+            <a:ext cx="3472806" cy="1925311"/>
+          </a:xfrm>
+          <a:prstGeom prst="rect">
+            <a:avLst/>
+          </a:prstGeom>
+        </p:spPr>
+      </p:pic>
     </p:spTree>
   </p:cSld>
   <p:clrMapOvr>

</xml_diff>